<commit_message>
Claims: holder claim kit — /claim/evidence downloads one passphrase-encrypted file (policy key + browser-sealed evidence + the exact fileClaim call) and policy-cover-preprod.mjs --claim <id> --kit <file> files it from the holder's own machine, re-checking the key against the Cardano datum and Midnight holder and the evidence against its commitment; SDK claimkit module + 7 tests; docs and test counts (SDK 97, Midnight 57)
</commit_message>
<xml_diff>
--- a/docs/buildathon/PlutusShield-Wave2-deck.pptx
+++ b/docs/buildathon/PlutusShield-Wave2-deck.pptx
@@ -7156,7 +7156,7 @@
                 </a:solidFill>
                 <a:latin typeface="Georgia"/>
               </a:rPr>
-              <a:t>295 unit tests plus an end-to-end emulator run, all green.</a:t>
+              <a:t>302 unit tests plus an end-to-end emulator run, all green.</a:t>
             </a:r>
           </a:p>
         </p:txBody>
@@ -7282,7 +7282,7 @@
                 </a:solidFill>
                 <a:latin typeface="Georgia"/>
               </a:rPr>
-              <a:t>92</a:t>
+              <a:t>97</a:t>
             </a:r>
           </a:p>
         </p:txBody>
@@ -7324,7 +7324,7 @@
                 </a:solidFill>
                 <a:latin typeface="Helvetica"/>
               </a:rPr>
-              <a:t>SDK: quote engine, codecs, evidence vault, relay</a:t>
+              <a:t>SDK: quote engine, codecs, evidence vault, claim kit, relay</a:t>
             </a:r>
           </a:p>
         </p:txBody>
@@ -7366,7 +7366,7 @@
                 </a:solidFill>
                 <a:latin typeface="Georgia"/>
               </a:rPr>
-              <a:t>55</a:t>
+              <a:t>57</a:t>
             </a:r>
           </a:p>
         </p:txBody>

</xml_diff>

<commit_message>
Claims: first holder-filed claim paid end to end — exploit policy 496dced8… (25 tADA, Preview v2 pool) filed from the holder's own claim kit on Midnight Preprod (fileClaim 00989a6a…, relay never held the policy key), seats 0 + 2 verified the bundle off-ledger and voted PAID (cefd3f5a…, beb6d9f5…), Cardano Settle dbf0ba7a… paid 25 tADA on assessor-1 + assessor-3 after the v2 Settle gate; /pool and /claim/evidence show the v2 committee decision and a 'filed by the holder' badge; README, settlement docs, Wave 2 deck rebuilt (305 tests)
</commit_message>
<xml_diff>
--- a/docs/buildathon/PlutusShield-Wave2-deck.pptx
+++ b/docs/buildathon/PlutusShield-Wave2-deck.pptx
@@ -7156,7 +7156,7 @@
                 </a:solidFill>
                 <a:latin typeface="Georgia"/>
               </a:rPr>
-              <a:t>302 unit tests plus an end-to-end emulator run, all green.</a:t>
+              <a:t>305 unit tests plus an end-to-end emulator run, all green.</a:t>
             </a:r>
           </a:p>
         </p:txBody>
@@ -7366,7 +7366,7 @@
                 </a:solidFill>
                 <a:latin typeface="Georgia"/>
               </a:rPr>
-              <a:t>57</a:t>
+              <a:t>60</a:t>
             </a:r>
           </a:p>
         </p:txBody>
@@ -7408,7 +7408,7 @@
                 </a:solidFill>
                 <a:latin typeface="Helvetica"/>
               </a:rPr>
-              <a:t>Compact circuit simulation, relay plan, state decode</a:t>
+              <a:t>Compact circuit simulation, claims relay, relay plan, state decode</a:t>
             </a:r>
           </a:p>
         </p:txBody>
@@ -8087,7 +8087,7 @@
                 </a:solidFill>
                 <a:latin typeface="Helvetica"/>
               </a:rPr>
-              <a:t>proveCover and fileClaim straight from the browser wallet.</a:t>
+              <a:t>proveCover and fileClaim straight from the browser wallet (claims already file from the holder's own claim kit).</a:t>
             </a:r>
           </a:p>
           <a:p>

</xml_diff>

<commit_message>
Web: Lace Midnight DApp Connector — discover window.midnight (never hardcode mnLace), connect on Preprod, show address + serviceUriConfig on /claim/evidence, /app, and the in-app header; SDK lace helpers + 10 tests (SDK 107); browser proveCover/fileClaim remains the next gap (claim kit still files today); README/Wave 2 deck/script updated (315 tests)
</commit_message>
<xml_diff>
--- a/docs/buildathon/PlutusShield-Wave2-deck.pptx
+++ b/docs/buildathon/PlutusShield-Wave2-deck.pptx
@@ -7156,7 +7156,7 @@
                 </a:solidFill>
                 <a:latin typeface="Georgia"/>
               </a:rPr>
-              <a:t>305 unit tests plus an end-to-end emulator run, all green.</a:t>
+              <a:t>315 unit tests plus an end-to-end emulator run, all green.</a:t>
             </a:r>
           </a:p>
         </p:txBody>
@@ -8087,7 +8087,7 @@
                 </a:solidFill>
                 <a:latin typeface="Helvetica"/>
               </a:rPr>
-              <a:t>proveCover and fileClaim straight from the browser wallet (claims already file from the holder's own claim kit).</a:t>
+              <a:t>Lace Midnight connect is live on the site; next is proveCover / fileClaim from that browser wallet (claims already file from the holder's claim kit).</a:t>
             </a:r>
           </a:p>
           <a:p>

</xml_diff>

<commit_message>
Web/SDK: Fetch ZK asset probe + browser Compact prover slot (verifier/zkir on Pages)
Add pure fetchZkConfig loader/probe (no midnight-js in SDK), laceCircuits
zk-assets readiness, Pages-safe verifier+zkir under public/zk/policy-cover-v2,
browserCircuit register/tryCreateMidnightJsProver + FileWithLace probe UI.
Prover keys stay local (sync-zk-assets.mjs). SDK 119 tests.
</commit_message>
<xml_diff>
--- a/docs/buildathon/PlutusShield-Wave2-deck.pptx
+++ b/docs/buildathon/PlutusShield-Wave2-deck.pptx
@@ -7156,7 +7156,7 @@
                 </a:solidFill>
                 <a:latin typeface="Georgia"/>
               </a:rPr>
-              <a:t>315 unit tests plus an end-to-end emulator run, all green.</a:t>
+              <a:t>327 unit tests plus an end-to-end emulator run, all green.</a:t>
             </a:r>
           </a:p>
         </p:txBody>
@@ -7282,7 +7282,7 @@
                 </a:solidFill>
                 <a:latin typeface="Georgia"/>
               </a:rPr>
-              <a:t>97</a:t>
+              <a:t>119</a:t>
             </a:r>
           </a:p>
         </p:txBody>
@@ -7324,7 +7324,7 @@
                 </a:solidFill>
                 <a:latin typeface="Helvetica"/>
               </a:rPr>
-              <a:t>SDK: quote engine, codecs, evidence vault, claim kit, relay</a:t>
+              <a:t>SDK: quote engine, codecs, evidence vault, claim kit, Lace, ZK fetch</a:t>
             </a:r>
           </a:p>
         </p:txBody>
@@ -8087,7 +8087,7 @@
                 </a:solidFill>
                 <a:latin typeface="Helvetica"/>
               </a:rPr>
-              <a:t>Lace Midnight connect is live on the site; next is proveCover / fileClaim from that browser wallet (claims already file from the holder's claim kit).</a:t>
+              <a:t>Lace circuit-submit + ZK asset probe (verifier/zkir on Pages) for proveCover / fileClaim on /claim/evidence; Compact prove still needs midnight-js injection — claim kit files today.</a:t>
             </a:r>
           </a:p>
           <a:p>

</xml_diff>

<commit_message>
Underwriting: open risk-tier scorecard on /docs/risk-tiers
SDK scoreRiskTier (packages/sdk/src/riskTier.ts): exploit and depeg rubrics
with points, hard stops that decline cover and caps on the best tier,
mapped to the risk_mult_bps a pool fixes at InitPool (live Preview pools
are tier B). 10 tests; SDK 136, total 344. Interactive scorecard on the
new docs page; linked from /cover's tier picker and /docs/pricing.
Deck and test counts refreshed.
</commit_message>
<xml_diff>
--- a/docs/buildathon/PlutusShield-Wave2-deck.pptx
+++ b/docs/buildathon/PlutusShield-Wave2-deck.pptx
@@ -7343,7 +7343,7 @@
                 </a:solidFill>
                 <a:latin typeface="Georgia"/>
               </a:rPr>
-              <a:t>334 unit tests plus an end-to-end emulator run, all green.</a:t>
+              <a:t>344 unit tests plus an end-to-end emulator run, all green.</a:t>
             </a:r>
           </a:p>
         </p:txBody>
@@ -7469,7 +7469,7 @@
                 </a:solidFill>
                 <a:latin typeface="Georgia"/>
               </a:rPr>
-              <a:t>126</a:t>
+              <a:t>136</a:t>
             </a:r>
           </a:p>
         </p:txBody>
@@ -7511,7 +7511,7 @@
                 </a:solidFill>
                 <a:latin typeface="Helvetica"/>
               </a:rPr>
-              <a:t>SDK: quote engine, codecs, evidence vault, claim kit, Lace, prove bridge</a:t>
+              <a:t>SDK: quote engine, risk tiers, codecs, evidence vault, claim kit, Lace, prove bridge</a:t>
             </a:r>
           </a:p>
         </p:txBody>

</xml_diff>

<commit_message>
Web: public underwriting book on /book
SDK LIVE_SCORECARDS for the USDM depeg and exploit-cover pools: concrete
scorecard answers that scoreRiskTier lands at tier B / risk_mult_bps 10_000
(4 tests; SDK 140, total 348). Web /book page lists each live Preview pool
(plus frozen exploit v1 as legacy) with read-only scorecard breakdown,
capital/utilization from pool snapshots, InitPool txs and explorer links —
same compile-time-from-records pattern as /claims. Footer, sitemap, README,
risk-tiers + underwriting-pool docs linked; deck counts refreshed.
</commit_message>
<xml_diff>
--- a/docs/buildathon/PlutusShield-Wave2-deck.pptx
+++ b/docs/buildathon/PlutusShield-Wave2-deck.pptx
@@ -7343,7 +7343,7 @@
                 </a:solidFill>
                 <a:latin typeface="Georgia"/>
               </a:rPr>
-              <a:t>344 unit tests plus an end-to-end emulator run, all green.</a:t>
+              <a:t>348 unit tests plus an end-to-end emulator run, all green.</a:t>
             </a:r>
           </a:p>
         </p:txBody>
@@ -7469,7 +7469,7 @@
                 </a:solidFill>
                 <a:latin typeface="Georgia"/>
               </a:rPr>
-              <a:t>136</a:t>
+              <a:t>140</a:t>
             </a:r>
           </a:p>
         </p:txBody>
@@ -7511,7 +7511,7 @@
                 </a:solidFill>
                 <a:latin typeface="Helvetica"/>
               </a:rPr>
-              <a:t>SDK: quote engine, risk tiers, codecs, evidence vault, claim kit, Lace, prove bridge</a:t>
+              <a:t>SDK: quote engine, risk tiers, underwriting book, codecs, evidence vault, claim kit, Lace, prove bridge</a:t>
             </a:r>
           </a:p>
         </p:txBody>

</xml_diff>

<commit_message>
Open data API: products, claims, book and oracle as versioned JSON feeds
Publishes /api/v1/{index,products,claims,book,oracle}.json on every static
build, from the same records /products, /claims, /book and /oracle render,
with Cardanoscan Preview / Midnight Preprod explorer URLs per transaction.
Each file sits in a plutusshield.open-data/v1 envelope (dataset, build time,
networks, testnetOnly, audited:false); amounts stay base-unit strings.

- SDK openData.ts: endpoint list, envelope builder, bigint-safe JSON,
  checkOpenDataEnvelope and fetchOpenData for integrators (6 tests, SDK 152)
- /docs/api page (datasets, envelope, curl + SDK examples, field notes,
  limits); docs nav, footer, sitemap via DOC_PAGES
- check-links now refuses a missing or mismatched feed after build
- Test report 360 + emulator; README roadmap, WAVE2_PROGRESS, deck rebuilt
</commit_message>
<xml_diff>
--- a/docs/buildathon/PlutusShield-Wave2-deck.pptx
+++ b/docs/buildathon/PlutusShield-Wave2-deck.pptx
@@ -7343,7 +7343,7 @@
                 </a:solidFill>
                 <a:latin typeface="Georgia"/>
               </a:rPr>
-              <a:t>354 unit tests plus an end-to-end emulator run, all green.</a:t>
+              <a:t>360 unit tests plus an end-to-end emulator run, all green.</a:t>
             </a:r>
           </a:p>
         </p:txBody>
@@ -7469,7 +7469,7 @@
                 </a:solidFill>
                 <a:latin typeface="Georgia"/>
               </a:rPr>
-              <a:t>146</a:t>
+              <a:t>152</a:t>
             </a:r>
           </a:p>
         </p:txBody>
@@ -7511,7 +7511,7 @@
                 </a:solidFill>
                 <a:latin typeface="Helvetica"/>
               </a:rPr>
-              <a:t>SDK: quote engine, risk tiers, underwriting book, codecs, evidence vault, claim kit, Lace, prove bridge</a:t>
+              <a:t>SDK: quote engine, risk tiers, underwriting book, open data, codecs, evidence vault, claim kit, Lace, prove bridge</a:t>
             </a:r>
           </a:p>
         </p:txBody>

</xml_diff>

<commit_message>
Activity feed: Atom /feed.xml of claim decisions, refused Settles and oracle publishes
- SDK atom.ts: buildAtomFeed / atomEntries / checkAtomFeed / activityTagId (RFC 4287, stable tag: ids, refuses duplicate ids, relative links, non-UTC times), 7 tests (SDK 159)
- apps/web/src/lib/activityFeed.ts builds 31 entries from the claims register and oracle history (6 claims, 1 refused Settle, newest 24 live publishes), each linked to its policy / oracle page and its Cardano Preview or Midnight Preprod tx
- Static route app/feed.xml, <link rel=alternate type=application/atom+xml> in every page head, footer link, /docs/api#feed section
- check-links validates feed.xml (structure, unique ids, escaping, Midnight tx links)
- README roadmap, Wave 2 progress, deck 367/159 rebuilt; test report refreshed
</commit_message>
<xml_diff>
--- a/docs/buildathon/PlutusShield-Wave2-deck.pptx
+++ b/docs/buildathon/PlutusShield-Wave2-deck.pptx
@@ -7343,7 +7343,7 @@
                 </a:solidFill>
                 <a:latin typeface="Georgia"/>
               </a:rPr>
-              <a:t>360 unit tests plus an end-to-end emulator run, all green.</a:t>
+              <a:t>367 unit tests plus an end-to-end emulator run, all green.</a:t>
             </a:r>
           </a:p>
         </p:txBody>
@@ -7469,7 +7469,7 @@
                 </a:solidFill>
                 <a:latin typeface="Georgia"/>
               </a:rPr>
-              <a:t>152</a:t>
+              <a:t>159</a:t>
             </a:r>
           </a:p>
         </p:txBody>
@@ -7511,7 +7511,7 @@
                 </a:solidFill>
                 <a:latin typeface="Helvetica"/>
               </a:rPr>
-              <a:t>SDK: quote engine, risk tiers, underwriting book, open data, codecs, evidence vault, claim kit, Lace, prove bridge</a:t>
+              <a:t>SDK: quote engine, risk tiers, underwriting book, open data, Atom feed, codecs, evidence vault, claim kit, Lace, prove bridge</a:t>
             </a:r>
           </a:p>
         </p:txBody>

</xml_diff>

<commit_message>
Cover planner: price a whole portfolio of exposures on /plan
planCover() in the SDK maps each stablecoin or protocol exposure to depeg or
exploit cover, splits anything over the 10% single-policy cap into several
policies, prices each with quote() on the utilization earlier policies leave,
stops at the 90% utilization cap and reports the remainder as uncovered.
SLA cover is never planned as a buy. 8 tests (SDK 167, total 375).

/plan runs it against the live Preview ADA / tUSDCx tranches from the pool
snapshots, with presets, per-policy Buy links and a premium-floor note.
Linked from /cover, the footer and the sitemap; README, test counts and the
Wave 2 deck updated.
</commit_message>
<xml_diff>
--- a/docs/buildathon/PlutusShield-Wave2-deck.pptx
+++ b/docs/buildathon/PlutusShield-Wave2-deck.pptx
@@ -7343,7 +7343,7 @@
                 </a:solidFill>
                 <a:latin typeface="Georgia"/>
               </a:rPr>
-              <a:t>367 unit tests plus an end-to-end emulator run, all green.</a:t>
+              <a:t>375 unit tests plus an end-to-end emulator run, all green.</a:t>
             </a:r>
           </a:p>
         </p:txBody>
@@ -7469,7 +7469,7 @@
                 </a:solidFill>
                 <a:latin typeface="Georgia"/>
               </a:rPr>
-              <a:t>159</a:t>
+              <a:t>167</a:t>
             </a:r>
           </a:p>
         </p:txBody>
@@ -7511,7 +7511,7 @@
                 </a:solidFill>
                 <a:latin typeface="Helvetica"/>
               </a:rPr>
-              <a:t>SDK: quote engine, risk tiers, underwriting book, open data, Atom feed, codecs, evidence vault, claim kit, Lace, prove bridge</a:t>
+              <a:t>SDK: quote engine, cover planner, risk tiers, underwriting book, open data, Atom feed, codecs, evidence vault, claim kit, Lace, prove bridge</a:t>
             </a:r>
           </a:p>
         </p:txBody>

</xml_diff>

<commit_message>
Embeddable cover quote: one iframe puts a live PlutusShield quote in a partner dApp
- SDK embed.ts: EmbedConfig codec (p, c, a, d, t, ref), lenient decode with
  warnings (term clamped, SLA refused), embedSnippet/embedUrl, resize
  postMessage script, embedQuote() = quote() + /plan share query; 9 tests
- /embed/quote/: bare widget (no site chrome), dark/light, amount, currency
  and term controls, opens the cover as a /plan link in a new tab; never
  touches a wallet
- /docs/embed: snippet builder with live preview, params, auto-size, SDK use
- README roadmap, Wave 2 progress, deck (SDK 180, total 388), test report
</commit_message>
<xml_diff>
--- a/docs/buildathon/PlutusShield-Wave2-deck.pptx
+++ b/docs/buildathon/PlutusShield-Wave2-deck.pptx
@@ -7343,7 +7343,7 @@
                 </a:solidFill>
                 <a:latin typeface="Georgia"/>
               </a:rPr>
-              <a:t>375 unit tests plus an end-to-end emulator run, all green.</a:t>
+              <a:t>388 unit tests plus an end-to-end emulator run, all green.</a:t>
             </a:r>
           </a:p>
         </p:txBody>
@@ -7469,7 +7469,7 @@
                 </a:solidFill>
                 <a:latin typeface="Georgia"/>
               </a:rPr>
-              <a:t>167</a:t>
+              <a:t>180</a:t>
             </a:r>
           </a:p>
         </p:txBody>
@@ -7511,7 +7511,7 @@
                 </a:solidFill>
                 <a:latin typeface="Helvetica"/>
               </a:rPr>
-              <a:t>SDK: quote engine, cover planner, risk tiers, underwriting book, open data, Atom feed, codecs, evidence vault, claim kit, Lace, prove bridge</a:t>
+              <a:t>SDK: quote engine, cover planner + shareable plans, embeddable quote widget, risk tiers, underwriting book, open data, Atom feed, codecs, evidence vault, claim kit, Lace, prove bridge</a:t>
             </a:r>
           </a:p>
         </p:txBody>

</xml_diff>

<commit_message>
Policy deadline calendar: export a policy's cover, expiry and claim deadline to .ics or Google Calendar from /policy
</commit_message>
<xml_diff>
--- a/docs/buildathon/PlutusShield-Wave2-deck.pptx
+++ b/docs/buildathon/PlutusShield-Wave2-deck.pptx
@@ -7343,7 +7343,7 @@
                 </a:solidFill>
                 <a:latin typeface="Georgia"/>
               </a:rPr>
-              <a:t>388 unit tests plus an end-to-end emulator run, all green.</a:t>
+              <a:t>396 unit tests plus an end-to-end emulator run, all green.</a:t>
             </a:r>
           </a:p>
         </p:txBody>
@@ -7469,7 +7469,7 @@
                 </a:solidFill>
                 <a:latin typeface="Georgia"/>
               </a:rPr>
-              <a:t>180</a:t>
+              <a:t>188</a:t>
             </a:r>
           </a:p>
         </p:txBody>
@@ -7511,7 +7511,7 @@
                 </a:solidFill>
                 <a:latin typeface="Helvetica"/>
               </a:rPr>
-              <a:t>SDK: quote engine, cover planner + shareable plans, embeddable quote widget, risk tiers, underwriting book, open data, Atom feed, codecs, evidence vault, claim kit, Lace, prove bridge</a:t>
+              <a:t>SDK: quote engine, cover planner + shareable plans, embeddable quote widget, policy deadline calendar, risk tiers, underwriting book, open data, Atom feed, codecs, evidence vault, claim kit, Lace, prove bridge</a:t>
             </a:r>
           </a:p>
         </p:txBody>

</xml_diff>

<commit_message>
Premium receipt: downloadable Buy proof on /policy from the Cardano Preview payment
</commit_message>
<xml_diff>
--- a/docs/buildathon/PlutusShield-Wave2-deck.pptx
+++ b/docs/buildathon/PlutusShield-Wave2-deck.pptx
@@ -7343,7 +7343,7 @@
                 </a:solidFill>
                 <a:latin typeface="Georgia"/>
               </a:rPr>
-              <a:t>409 unit tests plus an end-to-end emulator run, all green.</a:t>
+              <a:t>417 unit tests plus an end-to-end emulator run, all green.</a:t>
             </a:r>
           </a:p>
         </p:txBody>
@@ -7469,7 +7469,7 @@
                 </a:solidFill>
                 <a:latin typeface="Georgia"/>
               </a:rPr>
-              <a:t>201</a:t>
+              <a:t>209</a:t>
             </a:r>
           </a:p>
         </p:txBody>
@@ -7511,7 +7511,7 @@
                 </a:solidFill>
                 <a:latin typeface="Helvetica"/>
               </a:rPr>
-              <a:t>SDK: quote engine, cover wording, coverage certificate, cover planner + shareable plans, embeddable quote widget, policy deadline calendar, risk tiers, underwriting book, open data, Atom feed, codecs, evidence vault, claim kit, Lace, prove bridge</a:t>
+              <a:t>SDK: quote engine, cover wording, coverage certificate, premium receipt, cover planner + shareable plans, embeddable quote widget, policy deadline calendar, risk tiers, underwriting book, open data, Atom feed, codecs, evidence vault, claim kit, Lace, prove bridge</a:t>
             </a:r>
           </a:p>
         </p:txBody>

</xml_diff>